<commit_message>
chore: refresh gh-pages with restored site data
</commit_message>
<xml_diff>
--- a/site/preza.pptx
+++ b/site/preza.pptx
@@ -4218,13 +4218,6 @@
 <file path=ppt/slides/slide2.xml><?xml version="1.0" encoding="utf-8"?>
 <p:sld xmlns:a="http://schemas.openxmlformats.org/drawingml/2006/main" xmlns:r="http://schemas.openxmlformats.org/officeDocument/2006/relationships" xmlns:p="http://schemas.openxmlformats.org/presentationml/2006/main">
   <p:cSld name="Slide 2">
-    <p:bg>
-      <p:bgPr>
-        <a:solidFill>
-          <a:srgbClr val="0B3D91"/>
-        </a:solidFill>
-      </p:bgPr>
-    </p:bg>
     <p:spTree>
       <p:nvGrpSpPr>
         <p:cNvPr id="1" name=""/>
@@ -4247,8 +4240,8 @@
         </p:nvSpPr>
         <p:spPr>
           <a:xfrm>
-            <a:off x="548640" y="1051560"/>
-            <a:ext cx="8138160" cy="1097280"/>
+            <a:off x="502920" y="320040"/>
+            <a:ext cx="3657600" cy="457200"/>
           </a:xfrm>
           <a:prstGeom prst="rect">
             <a:avLst/>
@@ -4260,21 +4253,46 @@
           <a:bodyPr wrap="square" rtlCol="0" anchor="ctr"/>
           <a:lstStyle/>
           <a:p>
-            <a:pPr algn="ctr" indent="0" marL="0">
-              <a:buNone/>
-            </a:pPr>
-            <a:r>
-              <a:rPr lang="en-US" sz="2800" b="1" dirty="0">
-                <a:solidFill>
-                  <a:srgbClr val="FFFFFF"/>
-                </a:solidFill>
-                <a:latin typeface="Aptos" pitchFamily="34" charset="0"/>
-                <a:ea typeface="Aptos" pitchFamily="34" charset="-122"/>
-                <a:cs typeface="Aptos" pitchFamily="34" charset="-120"/>
-              </a:rPr>
-              <a:t>Визуализация и исследование данныхпри анализе классической литературына примере романа  “Война и мир”</a:t>
-            </a:r>
-            <a:endParaRPr lang="en-US" sz="2800" dirty="0"/>
+            <a:pPr indent="0" marL="0">
+              <a:buNone/>
+            </a:pPr>
+            <a:r>
+              <a:rPr lang="en-US" sz="2400" b="1" dirty="0">
+                <a:solidFill>
+                  <a:srgbClr val="17324D"/>
+                </a:solidFill>
+              </a:rPr>
+              <a:t>Визуализация и исследование данных</a:t>
+            </a:r>
+            <a:endParaRPr lang="en-US" sz="2400" dirty="0"/>
+          </a:p>
+          <a:p>
+            <a:pPr indent="0" marL="0">
+              <a:buNone/>
+            </a:pPr>
+            <a:r>
+              <a:rPr lang="en-US" sz="2400" b="1" dirty="0">
+                <a:solidFill>
+                  <a:srgbClr val="17324D"/>
+                </a:solidFill>
+              </a:rPr>
+              <a:t>при анализе классической литературы</a:t>
+            </a:r>
+            <a:endParaRPr lang="en-US" sz="2400" dirty="0"/>
+          </a:p>
+          <a:p>
+            <a:pPr indent="0" marL="0">
+              <a:buNone/>
+            </a:pPr>
+            <a:r>
+              <a:rPr lang="en-US" sz="2400" b="1" dirty="0">
+                <a:solidFill>
+                  <a:srgbClr val="17324D"/>
+                </a:solidFill>
+              </a:rPr>
+              <a:t>на примере романа “Война и мир”</a:t>
+            </a:r>
+            <a:endParaRPr lang="en-US" sz="2400" dirty="0"/>
           </a:p>
         </p:txBody>
       </p:sp>
@@ -4286,8 +4304,8 @@
         </p:nvSpPr>
         <p:spPr>
           <a:xfrm>
-            <a:off x="914400" y="2377440"/>
-            <a:ext cx="7315200" cy="640080"/>
+            <a:off x="502920" y="868680"/>
+            <a:ext cx="3657600" cy="640080"/>
           </a:xfrm>
           <a:prstGeom prst="rect">
             <a:avLst/>
@@ -4299,21 +4317,129 @@
           <a:bodyPr wrap="square" rtlCol="0" anchor="ctr"/>
           <a:lstStyle/>
           <a:p>
-            <a:pPr algn="ctr" indent="0" marL="0">
-              <a:buNone/>
-            </a:pPr>
-            <a:r>
-              <a:rPr lang="en-US" sz="1100" dirty="0">
-                <a:solidFill>
-                  <a:srgbClr val="DDE7FF"/>
-                </a:solidFill>
-              </a:rPr>
-              <a:t>Министерство образования Иркутской областиМинистерство по молодежной политике Иркутской областиСибирское отделение Российской академии наукРегиональная конференция проектно-исследовательских работ«Наука. Технологии. Интеллект»Для учащихся 8-11 классовобщеобразовательных учреждений Иркутской области</a:t>
-            </a:r>
-            <a:endParaRPr lang="en-US" sz="1100" dirty="0"/>
-          </a:p>
-        </p:txBody>
-      </p:sp>
+            <a:pPr indent="0" marL="0">
+              <a:buNone/>
+            </a:pPr>
+            <a:r>
+              <a:rPr lang="en-US" sz="1150" dirty="0">
+                <a:solidFill>
+                  <a:srgbClr val="52606D"/>
+                </a:solidFill>
+              </a:rPr>
+              <a:t>Министерство образования Иркутской области</a:t>
+            </a:r>
+            <a:endParaRPr lang="en-US" sz="1150" dirty="0"/>
+          </a:p>
+          <a:p>
+            <a:pPr indent="0" marL="0">
+              <a:buNone/>
+            </a:pPr>
+            <a:r>
+              <a:rPr lang="en-US" sz="1150" dirty="0">
+                <a:solidFill>
+                  <a:srgbClr val="52606D"/>
+                </a:solidFill>
+              </a:rPr>
+              <a:t>Министерство по молодежной политике Иркутской области</a:t>
+            </a:r>
+            <a:endParaRPr lang="en-US" sz="1150" dirty="0"/>
+          </a:p>
+          <a:p>
+            <a:pPr indent="0" marL="0">
+              <a:buNone/>
+            </a:pPr>
+            <a:r>
+              <a:rPr lang="en-US" sz="1150" dirty="0">
+                <a:solidFill>
+                  <a:srgbClr val="52606D"/>
+                </a:solidFill>
+              </a:rPr>
+              <a:t>Сибирское отделение Российской академии наук</a:t>
+            </a:r>
+            <a:endParaRPr lang="en-US" sz="1150" dirty="0"/>
+          </a:p>
+          <a:p>
+            <a:pPr indent="0" marL="0">
+              <a:buNone/>
+            </a:pPr>
+            <a:r>
+              <a:rPr lang="en-US" sz="1150" dirty="0">
+                <a:solidFill>
+                  <a:srgbClr val="52606D"/>
+                </a:solidFill>
+              </a:rPr>
+              <a:t>Региональная конференция проектно-исследовательских работ</a:t>
+            </a:r>
+            <a:endParaRPr lang="en-US" sz="1150" dirty="0"/>
+          </a:p>
+          <a:p>
+            <a:pPr indent="0" marL="0">
+              <a:buNone/>
+            </a:pPr>
+            <a:r>
+              <a:rPr lang="en-US" sz="1150" dirty="0">
+                <a:solidFill>
+                  <a:srgbClr val="52606D"/>
+                </a:solidFill>
+              </a:rPr>
+              <a:t>«Наука. Технологии. Интеллект»</a:t>
+            </a:r>
+            <a:endParaRPr lang="en-US" sz="1150" dirty="0"/>
+          </a:p>
+          <a:p>
+            <a:pPr indent="0" marL="0">
+              <a:buNone/>
+            </a:pPr>
+            <a:r>
+              <a:rPr lang="en-US" sz="1150" dirty="0">
+                <a:solidFill>
+                  <a:srgbClr val="52606D"/>
+                </a:solidFill>
+              </a:rPr>
+              <a:t>Для учащихся 8-11 классов</a:t>
+            </a:r>
+            <a:endParaRPr lang="en-US" sz="1150" dirty="0"/>
+          </a:p>
+          <a:p>
+            <a:pPr indent="0" marL="0">
+              <a:buNone/>
+            </a:pPr>
+            <a:r>
+              <a:rPr lang="en-US" sz="1150" dirty="0">
+                <a:solidFill>
+                  <a:srgbClr val="52606D"/>
+                </a:solidFill>
+              </a:rPr>
+              <a:t>общеобразовательных учреждений Иркутской области</a:t>
+            </a:r>
+            <a:endParaRPr lang="en-US" sz="1150" dirty="0"/>
+          </a:p>
+        </p:txBody>
+      </p:sp>
+      <p:pic>
+        <p:nvPicPr>
+          <p:cNvPr id="4" name="Image 0" descr="/home/az/Code/bukivedenie/site/presentation/slide-02-intro.png">    </p:cNvPr>
+          <p:cNvPicPr>
+            <a:picLocks noChangeAspect="1"/>
+          </p:cNvPicPr>
+          <p:nvPr/>
+        </p:nvPicPr>
+        <p:blipFill>
+          <a:blip r:embed="rId1"/>
+          <a:stretch>
+            <a:fillRect/>
+          </a:stretch>
+        </p:blipFill>
+        <p:spPr>
+          <a:xfrm>
+            <a:off x="4343400" y="502920"/>
+            <a:ext cx="3840480" cy="2651760"/>
+          </a:xfrm>
+          <a:prstGeom prst="rect">
+            <a:avLst/>
+          </a:prstGeom>
+        </p:spPr>
+      </p:pic>
     </p:spTree>
   </p:cSld>
   <p:clrMapOvr>
@@ -4711,7 +4837,7 @@
         <p:spPr>
           <a:xfrm>
             <a:off x="502920" y="320040"/>
-            <a:ext cx="7772400" cy="411480"/>
+            <a:ext cx="3657600" cy="457200"/>
           </a:xfrm>
           <a:prstGeom prst="rect">
             <a:avLst/>
@@ -4727,14 +4853,14 @@
               <a:buNone/>
             </a:pPr>
             <a:r>
-              <a:rPr lang="en-US" sz="2200" b="1" dirty="0">
-                <a:solidFill>
-                  <a:srgbClr val="1C2833"/>
+              <a:rPr lang="en-US" sz="2400" b="1" dirty="0">
+                <a:solidFill>
+                  <a:srgbClr val="17324D"/>
                 </a:solidFill>
               </a:rPr>
               <a:t>Реализация и выводы</a:t>
             </a:r>
-            <a:endParaRPr lang="en-US" sz="2200" dirty="0"/>
+            <a:endParaRPr lang="en-US" sz="2400" dirty="0"/>
           </a:p>
         </p:txBody>
       </p:sp>
@@ -4746,8 +4872,8 @@
         </p:nvSpPr>
         <p:spPr>
           <a:xfrm>
-            <a:off x="502920" y="3657600"/>
-            <a:ext cx="3886200" cy="2514600"/>
+            <a:off x="502920" y="1554480"/>
+            <a:ext cx="3657600" cy="3200400"/>
           </a:xfrm>
           <a:prstGeom prst="rect">
             <a:avLst/>
@@ -4765,7 +4891,7 @@
             <a:r>
               <a:rPr lang="en-US" sz="1100" dirty="0">
                 <a:solidFill>
-                  <a:srgbClr val="1C2833"/>
+                  <a:srgbClr val="17324D"/>
                 </a:solidFill>
               </a:rPr>
               <a:t>Проект показывает полный конвейер: от текста до визуализаций и статической витрины. Все артефакты хранятся в outputs/&amp;lt;book_id&amp;gt;/ и экспортируются в site/public/data/.</a:t>
@@ -4785,7 +4911,7 @@
             <a:r>
               <a:rPr lang="en-US" sz="1100" dirty="0">
                 <a:solidFill>
-                  <a:srgbClr val="1C2833"/>
+                  <a:srgbClr val="17324D"/>
                 </a:solidFill>
               </a:rPr>
               <a:t>Следующие шаги — улучшение выделения именованных сущностей, проверка персонажей, сравнение изданий и масштабирование на корпус.</a:t>
@@ -4805,13 +4931,6 @@
 <file path=ppt/slides/slide24.xml><?xml version="1.0" encoding="utf-8"?>
 <p:sld xmlns:a="http://schemas.openxmlformats.org/drawingml/2006/main" xmlns:r="http://schemas.openxmlformats.org/officeDocument/2006/relationships" xmlns:p="http://schemas.openxmlformats.org/presentationml/2006/main">
   <p:cSld name="Slide 24">
-    <p:bg>
-      <p:bgPr>
-        <a:solidFill>
-          <a:srgbClr val="F6F8FC"/>
-        </a:solidFill>
-      </p:bgPr>
-    </p:bg>
     <p:spTree>
       <p:nvGrpSpPr>
         <p:cNvPr id="1" name=""/>
@@ -4834,8 +4953,8 @@
         </p:nvSpPr>
         <p:spPr>
           <a:xfrm>
-            <a:off x="914400" y="1371600"/>
-            <a:ext cx="6949440" cy="548640"/>
+            <a:off x="502920" y="320040"/>
+            <a:ext cx="3657600" cy="457200"/>
           </a:xfrm>
           <a:prstGeom prst="rect">
             <a:avLst/>
@@ -4847,18 +4966,18 @@
           <a:bodyPr wrap="square" rtlCol="0" anchor="ctr"/>
           <a:lstStyle/>
           <a:p>
-            <a:pPr algn="ctr" indent="0" marL="0">
-              <a:buNone/>
-            </a:pPr>
-            <a:r>
-              <a:rPr lang="en-US" sz="2600" b="1" dirty="0">
-                <a:solidFill>
-                  <a:srgbClr val="0F2742"/>
+            <a:pPr indent="0" marL="0">
+              <a:buNone/>
+            </a:pPr>
+            <a:r>
+              <a:rPr lang="en-US" sz="2400" b="1" dirty="0">
+                <a:solidFill>
+                  <a:srgbClr val="17324D"/>
                 </a:solidFill>
               </a:rPr>
               <a:t>Спасибо за внимание</a:t>
             </a:r>
-            <a:endParaRPr lang="en-US" sz="2600" dirty="0"/>
+            <a:endParaRPr lang="en-US" sz="2400" dirty="0"/>
           </a:p>
         </p:txBody>
       </p:sp>
@@ -4870,8 +4989,8 @@
         </p:nvSpPr>
         <p:spPr>
           <a:xfrm>
-            <a:off x="914400" y="2057400"/>
-            <a:ext cx="6949440" cy="640080"/>
+            <a:off x="502920" y="868680"/>
+            <a:ext cx="3657600" cy="640080"/>
           </a:xfrm>
           <a:prstGeom prst="rect">
             <a:avLst/>
@@ -4883,18 +5002,18 @@
           <a:bodyPr wrap="square" rtlCol="0" anchor="ctr"/>
           <a:lstStyle/>
           <a:p>
-            <a:pPr algn="ctr" indent="0" marL="0">
-              <a:buNone/>
-            </a:pPr>
-            <a:r>
-              <a:rPr lang="en-US" sz="1200" dirty="0">
+            <a:pPr indent="0" marL="0">
+              <a:buNone/>
+            </a:pPr>
+            <a:r>
+              <a:rPr lang="en-US" sz="1150" dirty="0">
                 <a:solidFill>
                   <a:srgbClr val="52606D"/>
                 </a:solidFill>
               </a:rPr>
               <a:t>Вопросы, замечания и дополнительные материалы доступны в репозитории.</a:t>
             </a:r>
-            <a:endParaRPr lang="en-US" sz="1200" dirty="0"/>
+            <a:endParaRPr lang="en-US" sz="1150" dirty="0"/>
           </a:p>
         </p:txBody>
       </p:sp>
@@ -4932,7 +5051,7 @@
         <p:spPr>
           <a:xfrm>
             <a:off x="502920" y="320040"/>
-            <a:ext cx="7772400" cy="411480"/>
+            <a:ext cx="3657600" cy="457200"/>
           </a:xfrm>
           <a:prstGeom prst="rect">
             <a:avLst/>
@@ -4948,14 +5067,14 @@
               <a:buNone/>
             </a:pPr>
             <a:r>
-              <a:rPr lang="en-US" sz="2200" b="1" dirty="0">
-                <a:solidFill>
-                  <a:srgbClr val="1C2833"/>
+              <a:rPr lang="en-US" sz="2400" b="1" dirty="0">
+                <a:solidFill>
+                  <a:srgbClr val="17324D"/>
                 </a:solidFill>
               </a:rPr>
               <a:t>Введение</a:t>
             </a:r>
-            <a:endParaRPr lang="en-US" sz="2200" dirty="0"/>
+            <a:endParaRPr lang="en-US" sz="2400" dirty="0"/>
           </a:p>
         </p:txBody>
       </p:sp>
@@ -4967,8 +5086,8 @@
         </p:nvSpPr>
         <p:spPr>
           <a:xfrm>
-            <a:off x="502920" y="3657600"/>
-            <a:ext cx="3886200" cy="2514600"/>
+            <a:off x="502920" y="1554480"/>
+            <a:ext cx="3657600" cy="3200400"/>
           </a:xfrm>
           <a:prstGeom prst="rect">
             <a:avLst/>
@@ -4986,7 +5105,7 @@
             <a:r>
               <a:rPr lang="en-US" sz="1100" dirty="0">
                 <a:solidFill>
-                  <a:srgbClr val="1C2833"/>
+                  <a:srgbClr val="17324D"/>
                 </a:solidFill>
               </a:rPr>
               <a:t>Цель: создать открытый и воспроизводимый способ анализа текста и построения визуализаций для крупного литературного произведения.</a:t>
@@ -5006,7 +5125,7 @@
             <a:r>
               <a:rPr lang="en-US" sz="1100" dirty="0">
                 <a:solidFill>
-                  <a:srgbClr val="1C2833"/>
+                  <a:srgbClr val="17324D"/>
                 </a:solidFill>
               </a:rPr>
               <a:t>Задачи:</a:t>
@@ -5026,7 +5145,7 @@
             <a:r>
               <a:rPr lang="en-US" sz="1100" dirty="0">
                 <a:solidFill>
-                  <a:srgbClr val="1C2833"/>
+                  <a:srgbClr val="17324D"/>
                 </a:solidFill>
               </a:rPr>
               <a:t>• разработать понятный формат визуализаций;</a:t>
@@ -5046,7 +5165,7 @@
             <a:r>
               <a:rPr lang="en-US" sz="1100" dirty="0">
                 <a:solidFill>
-                  <a:srgbClr val="1C2833"/>
+                  <a:srgbClr val="17324D"/>
                 </a:solidFill>
               </a:rPr>
               <a:t>• автоматизировать сбор и подготовку данных из текста;</a:t>
@@ -5066,7 +5185,7 @@
             <a:r>
               <a:rPr lang="en-US" sz="1100" dirty="0">
                 <a:solidFill>
-                  <a:srgbClr val="1C2833"/>
+                  <a:srgbClr val="17324D"/>
                 </a:solidFill>
               </a:rPr>
               <a:t>• построить наглядные визуализации;</a:t>
@@ -5086,7 +5205,7 @@
             <a:r>
               <a:rPr lang="en-US" sz="1100" dirty="0">
                 <a:solidFill>
-                  <a:srgbClr val="1C2833"/>
+                  <a:srgbClr val="17324D"/>
                 </a:solidFill>
               </a:rPr>
               <a:t>• опубликовать результат в открытом доступе.</a:t>
@@ -5129,7 +5248,7 @@
         <p:spPr>
           <a:xfrm>
             <a:off x="502920" y="320040"/>
-            <a:ext cx="7772400" cy="411480"/>
+            <a:ext cx="3657600" cy="457200"/>
           </a:xfrm>
           <a:prstGeom prst="rect">
             <a:avLst/>
@@ -5145,14 +5264,14 @@
               <a:buNone/>
             </a:pPr>
             <a:r>
-              <a:rPr lang="en-US" sz="2200" b="1" dirty="0">
-                <a:solidFill>
-                  <a:srgbClr val="1C2833"/>
+              <a:rPr lang="en-US" sz="2400" b="1" dirty="0">
+                <a:solidFill>
+                  <a:srgbClr val="17324D"/>
                 </a:solidFill>
               </a:rPr>
               <a:t>Система разработки на телефоне</a:t>
             </a:r>
-            <a:endParaRPr lang="en-US" sz="2200" dirty="0"/>
+            <a:endParaRPr lang="en-US" sz="2400" dirty="0"/>
           </a:p>
         </p:txBody>
       </p:sp>
@@ -5164,8 +5283,8 @@
         </p:nvSpPr>
         <p:spPr>
           <a:xfrm>
-            <a:off x="502920" y="3657600"/>
-            <a:ext cx="3886200" cy="2514600"/>
+            <a:off x="502920" y="1554480"/>
+            <a:ext cx="3657600" cy="3200400"/>
           </a:xfrm>
           <a:prstGeom prst="rect">
             <a:avLst/>
@@ -5183,7 +5302,7 @@
             <a:r>
               <a:rPr lang="en-US" sz="1100" dirty="0">
                 <a:solidFill>
-                  <a:srgbClr val="1C2833"/>
+                  <a:srgbClr val="17324D"/>
                 </a:solidFill>
               </a:rPr>
               <a:t>Инструменты:</a:t>
@@ -5203,7 +5322,7 @@
             <a:r>
               <a:rPr lang="en-US" sz="1100" dirty="0">
                 <a:solidFill>
-                  <a:srgbClr val="1C2833"/>
+                  <a:srgbClr val="17324D"/>
                 </a:solidFill>
               </a:rPr>
               <a:t>• Markor — черновики и заметки.</a:t>
@@ -5223,7 +5342,7 @@
             <a:r>
               <a:rPr lang="en-US" sz="1100" dirty="0">
                 <a:solidFill>
-                  <a:srgbClr val="1C2833"/>
+                  <a:srgbClr val="17324D"/>
                 </a:solidFill>
               </a:rPr>
               <a:t>• Termux — рабочая среда на Android.</a:t>
@@ -5243,7 +5362,7 @@
             <a:r>
               <a:rPr lang="en-US" sz="1100" dirty="0">
                 <a:solidFill>
-                  <a:srgbClr val="1C2833"/>
+                  <a:srgbClr val="17324D"/>
                 </a:solidFill>
               </a:rPr>
               <a:t>• GitHub — хранение и публикация проекта.</a:t>
@@ -5263,7 +5382,7 @@
             <a:r>
               <a:rPr lang="en-US" sz="1100" dirty="0">
                 <a:solidFill>
-                  <a:srgbClr val="1C2833"/>
+                  <a:srgbClr val="17324D"/>
                 </a:solidFill>
               </a:rPr>
               <a:t>• PI — помощник при написании кода.</a:t>
@@ -5283,7 +5402,7 @@
             <a:r>
               <a:rPr lang="en-US" sz="1100" dirty="0">
                 <a:solidFill>
-                  <a:srgbClr val="1C2833"/>
+                  <a:srgbClr val="17324D"/>
                 </a:solidFill>
               </a:rPr>
               <a:t>• Python — обработка текста и данных.</a:t>
@@ -5303,7 +5422,7 @@
             <a:r>
               <a:rPr lang="en-US" sz="1100" dirty="0">
                 <a:solidFill>
-                  <a:srgbClr val="1C2833"/>
+                  <a:srgbClr val="17324D"/>
                 </a:solidFill>
               </a:rPr>
               <a:t>• JS — веб-витрина визуализаций.</a:t>
@@ -5346,7 +5465,7 @@
         <p:spPr>
           <a:xfrm>
             <a:off x="502920" y="320040"/>
-            <a:ext cx="7772400" cy="411480"/>
+            <a:ext cx="3657600" cy="457200"/>
           </a:xfrm>
           <a:prstGeom prst="rect">
             <a:avLst/>
@@ -5362,14 +5481,14 @@
               <a:buNone/>
             </a:pPr>
             <a:r>
-              <a:rPr lang="en-US" sz="2200" b="1" dirty="0">
-                <a:solidFill>
-                  <a:srgbClr val="1C2833"/>
+              <a:rPr lang="en-US" sz="2400" b="1" dirty="0">
+                <a:solidFill>
+                  <a:srgbClr val="17324D"/>
                 </a:solidFill>
               </a:rPr>
               <a:t>Сбор данных</a:t>
             </a:r>
-            <a:endParaRPr lang="en-US" sz="2200" dirty="0"/>
+            <a:endParaRPr lang="en-US" sz="2400" dirty="0"/>
           </a:p>
         </p:txBody>
       </p:sp>
@@ -5381,8 +5500,8 @@
         </p:nvSpPr>
         <p:spPr>
           <a:xfrm>
-            <a:off x="502920" y="3657600"/>
-            <a:ext cx="3886200" cy="2514600"/>
+            <a:off x="502920" y="1554480"/>
+            <a:ext cx="3657600" cy="3200400"/>
           </a:xfrm>
           <a:prstGeom prst="rect">
             <a:avLst/>
@@ -5400,7 +5519,7 @@
             <a:r>
               <a:rPr lang="en-US" sz="1100" dirty="0">
                 <a:solidFill>
-                  <a:srgbClr val="1C2833"/>
+                  <a:srgbClr val="17324D"/>
                 </a:solidFill>
               </a:rPr>
               <a:t>Пайплайн:</a:t>
@@ -5420,7 +5539,7 @@
             <a:r>
               <a:rPr lang="en-US" sz="1100" dirty="0">
                 <a:solidFill>
-                  <a:srgbClr val="1C2833"/>
+                  <a:srgbClr val="17324D"/>
                 </a:solidFill>
               </a:rPr>
               <a:t>• нормализация текста (UTF-8, единые кавычки и тире);</a:t>
@@ -5440,7 +5559,7 @@
             <a:r>
               <a:rPr lang="en-US" sz="1100" dirty="0">
                 <a:solidFill>
-                  <a:srgbClr val="1C2833"/>
+                  <a:srgbClr val="17324D"/>
                 </a:solidFill>
               </a:rPr>
               <a:t>• разбиение на токены;</a:t>
@@ -5460,7 +5579,7 @@
             <a:r>
               <a:rPr lang="en-US" sz="1100" dirty="0">
                 <a:solidFill>
-                  <a:srgbClr val="1C2833"/>
+                  <a:srgbClr val="17324D"/>
                 </a:solidFill>
               </a:rPr>
               <a:t>• разбиение на предложения, абзацы, главы и диалоги;</a:t>
@@ -5480,7 +5599,7 @@
             <a:r>
               <a:rPr lang="en-US" sz="1100" dirty="0">
                 <a:solidFill>
-                  <a:srgbClr val="1C2833"/>
+                  <a:srgbClr val="17324D"/>
                 </a:solidFill>
               </a:rPr>
               <a:t>• лемматизация слов;</a:t>
@@ -5500,7 +5619,7 @@
             <a:r>
               <a:rPr lang="en-US" sz="1100" dirty="0">
                 <a:solidFill>
-                  <a:srgbClr val="1C2833"/>
+                  <a:srgbClr val="17324D"/>
                 </a:solidFill>
               </a:rPr>
               <a:t>• выделение имен собственных и их связей в тексте;</a:t>
@@ -5520,7 +5639,7 @@
             <a:r>
               <a:rPr lang="en-US" sz="1100" dirty="0">
                 <a:solidFill>
-                  <a:srgbClr val="1C2833"/>
+                  <a:srgbClr val="17324D"/>
                 </a:solidFill>
               </a:rPr>
               <a:t>• подсчет метрик сложности и тональности;</a:t>
@@ -5540,7 +5659,7 @@
             <a:r>
               <a:rPr lang="en-US" sz="1100" dirty="0">
                 <a:solidFill>
-                  <a:srgbClr val="1C2833"/>
+                  <a:srgbClr val="17324D"/>
                 </a:solidFill>
               </a:rPr>
               <a:t>• вывод данных в таблицы JSON и CSV.</a:t>
@@ -5583,7 +5702,7 @@
         <p:spPr>
           <a:xfrm>
             <a:off x="502920" y="320040"/>
-            <a:ext cx="7772400" cy="411480"/>
+            <a:ext cx="3657600" cy="457200"/>
           </a:xfrm>
           <a:prstGeom prst="rect">
             <a:avLst/>
@@ -5599,14 +5718,14 @@
               <a:buNone/>
             </a:pPr>
             <a:r>
-              <a:rPr lang="en-US" sz="2200" b="1" dirty="0">
-                <a:solidFill>
-                  <a:srgbClr val="1C2833"/>
+              <a:rPr lang="en-US" sz="2400" b="1" dirty="0">
+                <a:solidFill>
+                  <a:srgbClr val="17324D"/>
                 </a:solidFill>
               </a:rPr>
               <a:t>Визуализация</a:t>
             </a:r>
-            <a:endParaRPr lang="en-US" sz="2200" dirty="0"/>
+            <a:endParaRPr lang="en-US" sz="2400" dirty="0"/>
           </a:p>
         </p:txBody>
       </p:sp>
@@ -5618,8 +5737,8 @@
         </p:nvSpPr>
         <p:spPr>
           <a:xfrm>
-            <a:off x="502920" y="3657600"/>
-            <a:ext cx="3886200" cy="2514600"/>
+            <a:off x="502920" y="1554480"/>
+            <a:ext cx="3657600" cy="3200400"/>
           </a:xfrm>
           <a:prstGeom prst="rect">
             <a:avLst/>
@@ -5637,7 +5756,7 @@
             <a:r>
               <a:rPr lang="en-US" sz="1100" dirty="0">
                 <a:solidFill>
-                  <a:srgbClr val="1C2833"/>
+                  <a:srgbClr val="17324D"/>
                 </a:solidFill>
               </a:rPr>
               <a:t>• Визуализации сделаны на JavaScript без API и внешних серверов.</a:t>
@@ -5657,7 +5776,7 @@
             <a:r>
               <a:rPr lang="en-US" sz="1100" dirty="0">
                 <a:solidFill>
-                  <a:srgbClr val="1C2833"/>
+                  <a:srgbClr val="17324D"/>
                 </a:solidFill>
               </a:rPr>
               <a:t>• Проект выложен в GitHub и запускается локально как статический сайт.</a:t>
@@ -5700,7 +5819,7 @@
         <p:spPr>
           <a:xfrm>
             <a:off x="502920" y="320040"/>
-            <a:ext cx="7772400" cy="411480"/>
+            <a:ext cx="3657600" cy="457200"/>
           </a:xfrm>
           <a:prstGeom prst="rect">
             <a:avLst/>
@@ -5716,14 +5835,14 @@
               <a:buNone/>
             </a:pPr>
             <a:r>
-              <a:rPr lang="en-US" sz="2200" b="1" dirty="0">
-                <a:solidFill>
-                  <a:srgbClr val="1C2833"/>
+              <a:rPr lang="en-US" sz="2400" b="1" dirty="0">
+                <a:solidFill>
+                  <a:srgbClr val="17324D"/>
                 </a:solidFill>
               </a:rPr>
               <a:t>Реализация кода при помощи агента.</a:t>
             </a:r>
-            <a:endParaRPr lang="en-US" sz="2200" dirty="0"/>
+            <a:endParaRPr lang="en-US" sz="2400" dirty="0"/>
           </a:p>
         </p:txBody>
       </p:sp>
@@ -5735,8 +5854,8 @@
         </p:nvSpPr>
         <p:spPr>
           <a:xfrm>
-            <a:off x="502920" y="3657600"/>
-            <a:ext cx="3886200" cy="2514600"/>
+            <a:off x="502920" y="1554480"/>
+            <a:ext cx="3657600" cy="3200400"/>
           </a:xfrm>
           <a:prstGeom prst="rect">
             <a:avLst/>
@@ -5754,7 +5873,7 @@
             <a:r>
               <a:rPr lang="en-US" sz="1100" dirty="0">
                 <a:solidFill>
-                  <a:srgbClr val="1C2833"/>
+                  <a:srgbClr val="17324D"/>
                 </a:solidFill>
               </a:rPr>
               <a:t>В разработке я использовала агента PI.</a:t>
@@ -5774,7 +5893,7 @@
             <a:r>
               <a:rPr lang="en-US" sz="1100" dirty="0">
                 <a:solidFill>
-                  <a:srgbClr val="1C2833"/>
+                  <a:srgbClr val="17324D"/>
                 </a:solidFill>
               </a:rPr>
               <a:t>• Ему нужна максимально подробная спецификация.</a:t>
@@ -5794,7 +5913,7 @@
             <a:r>
               <a:rPr lang="en-US" sz="1100" dirty="0">
                 <a:solidFill>
-                  <a:srgbClr val="1C2833"/>
+                  <a:srgbClr val="17324D"/>
                 </a:solidFill>
               </a:rPr>
               <a:t>• Он быстро пишет большой объем кода.</a:t>
@@ -5814,7 +5933,7 @@
             <a:r>
               <a:rPr lang="en-US" sz="1100" dirty="0">
                 <a:solidFill>
-                  <a:srgbClr val="1C2833"/>
+                  <a:srgbClr val="17324D"/>
                 </a:solidFill>
               </a:rPr>
               <a:t>• Его нужно внимательно читать, чтобы не накапливать когнитивный долг.</a:t>
@@ -5834,7 +5953,7 @@
             <a:r>
               <a:rPr lang="en-US" sz="1100" dirty="0">
                 <a:solidFill>
-                  <a:srgbClr val="1C2833"/>
+                  <a:srgbClr val="17324D"/>
                 </a:solidFill>
               </a:rPr>
               <a:t>• Он склонен усложнять структуру репозитория.</a:t>
@@ -5854,7 +5973,7 @@
             <a:r>
               <a:rPr lang="en-US" sz="1100" dirty="0">
                 <a:solidFill>
-                  <a:srgbClr val="1C2833"/>
+                  <a:srgbClr val="17324D"/>
                 </a:solidFill>
               </a:rPr>
               <a:t>• После генерации нужен рефакторинг.</a:t>
@@ -5874,13 +5993,6 @@
 <file path=ppt/slides/slide8.xml><?xml version="1.0" encoding="utf-8"?>
 <p:sld xmlns:a="http://schemas.openxmlformats.org/drawingml/2006/main" xmlns:r="http://schemas.openxmlformats.org/officeDocument/2006/relationships" xmlns:p="http://schemas.openxmlformats.org/presentationml/2006/main">
   <p:cSld name="Slide 8">
-    <p:bg>
-      <p:bgPr>
-        <a:solidFill>
-          <a:srgbClr val="F6F8FC"/>
-        </a:solidFill>
-      </p:bgPr>
-    </p:bg>
     <p:spTree>
       <p:nvGrpSpPr>
         <p:cNvPr id="1" name=""/>
@@ -5903,8 +6015,8 @@
         </p:nvSpPr>
         <p:spPr>
           <a:xfrm>
-            <a:off x="914400" y="1371600"/>
-            <a:ext cx="6949440" cy="548640"/>
+            <a:off x="502920" y="320040"/>
+            <a:ext cx="3657600" cy="457200"/>
           </a:xfrm>
           <a:prstGeom prst="rect">
             <a:avLst/>
@@ -5916,18 +6028,18 @@
           <a:bodyPr wrap="square" rtlCol="0" anchor="ctr"/>
           <a:lstStyle/>
           <a:p>
-            <a:pPr algn="ctr" indent="0" marL="0">
-              <a:buNone/>
-            </a:pPr>
-            <a:r>
-              <a:rPr lang="en-US" sz="2600" b="1" dirty="0">
-                <a:solidFill>
-                  <a:srgbClr val="0F2742"/>
+            <a:pPr indent="0" marL="0">
+              <a:buNone/>
+            </a:pPr>
+            <a:r>
+              <a:rPr lang="en-US" sz="2400" b="1" dirty="0">
+                <a:solidFill>
+                  <a:srgbClr val="17324D"/>
                 </a:solidFill>
               </a:rPr>
               <a:t>Спасибо за внимание.</a:t>
             </a:r>
-            <a:endParaRPr lang="en-US" sz="2600" dirty="0"/>
+            <a:endParaRPr lang="en-US" sz="2400" dirty="0"/>
           </a:p>
         </p:txBody>
       </p:sp>
@@ -5939,8 +6051,8 @@
         </p:nvSpPr>
         <p:spPr>
           <a:xfrm>
-            <a:off x="914400" y="2057400"/>
-            <a:ext cx="6949440" cy="640080"/>
+            <a:off x="502920" y="868680"/>
+            <a:ext cx="3657600" cy="640080"/>
           </a:xfrm>
           <a:prstGeom prst="rect">
             <a:avLst/>
@@ -5952,18 +6064,18 @@
           <a:bodyPr wrap="square" rtlCol="0" anchor="ctr"/>
           <a:lstStyle/>
           <a:p>
-            <a:pPr algn="ctr" indent="0" marL="0">
-              <a:buNone/>
-            </a:pPr>
-            <a:r>
-              <a:rPr lang="en-US" sz="1200" dirty="0">
+            <a:pPr indent="0" marL="0">
+              <a:buNone/>
+            </a:pPr>
+            <a:r>
+              <a:rPr lang="en-US" sz="1150" dirty="0">
                 <a:solidFill>
                   <a:srgbClr val="52606D"/>
                 </a:solidFill>
               </a:rPr>
               <a:t>Дополнительные материалы, визуализации и код доступны в репозитории.</a:t>
             </a:r>
-            <a:endParaRPr lang="en-US" sz="1200" dirty="0"/>
+            <a:endParaRPr lang="en-US" sz="1150" dirty="0"/>
           </a:p>
         </p:txBody>
       </p:sp>

</xml_diff>